<commit_message>
Feat: Add mobile home screen icon, PWA manifests, and set title to LN Sales Review App
</commit_message>
<xml_diff>
--- a/Egy_Nutri_Business_Review_Deck.pptx
+++ b/Egy_Nutri_Business_Review_Deck.pptx
@@ -1554,7 +1554,7 @@
             <c:size val="6"/>
             <c:spPr>
               <a:solidFill>
-                <a:srgbClr val="F59E0B"/>
+                <a:srgbClr val="10B981"/>
               </a:solidFill>
               <a:ln w="9525" cap="flat">
                 <a:solidFill>
@@ -1674,7 +1674,7 @@
             <c:size val="6"/>
             <c:spPr>
               <a:solidFill>
-                <a:srgbClr val="10B981"/>
+                <a:srgbClr val="F59E0B"/>
               </a:solidFill>
               <a:ln w="9525" cap="flat">
                 <a:solidFill>

</xml_diff>

<commit_message>
fix(slide11): resolve blank slide display and implement 3-Horizon Velocity Trilogy (Q3 vs H1 vs 2025)
</commit_message>
<xml_diff>
--- a/Egy_Nutri_Business_Review_Deck.pptx
+++ b/Egy_Nutri_Business_Review_Deck.pptx
@@ -1555,7 +1555,7 @@
             <c:size val="6"/>
             <c:spPr>
               <a:solidFill>
-                <a:srgbClr val="10B981"/>
+                <a:srgbClr val="F59E0B"/>
               </a:solidFill>
               <a:ln w="9525" cap="flat">
                 <a:solidFill>
@@ -10106,7 +10106,7 @@
                 <a:ea typeface="Calibri" pitchFamily="34" charset="-122"/>
                 <a:cs typeface="Calibri" pitchFamily="34" charset="-120"/>
               </a:rPr>
-              <a:t>MEDICAL REP / ADM QUARTERLY VELOCITY: Q3 2026 vs H1 2026 BASELINE</a:t>
+              <a:t>3-HORIZON RUN-RATE VELOCITY: Q3 2026 vs H1 2026 BASELINE vs 2025</a:t>
             </a:r>
             <a:endParaRPr lang="en-US" sz="1650" dirty="0"/>
           </a:p>
@@ -10145,7 +10145,7 @@
                 <a:ea typeface="Calibri" pitchFamily="34" charset="-122"/>
                 <a:cs typeface="Calibri" pitchFamily="34" charset="-120"/>
               </a:rPr>
-              <a:t>Evaluating Run-Rate Acceleration: National Monthly Average grew from 138,315 to 156,126 cans/mo (+12.9%)</a:t>
+              <a:t>Commercial Velocity Trilogy: Tracking Medical Rep Momentum from 2025 Baseline through H1 2026 to Q3 2026 (+51.0% vs '25)</a:t>
             </a:r>
             <a:endParaRPr lang="en-US" sz="1000" dirty="0"/>
           </a:p>
@@ -10244,11 +10244,11 @@
             <a:avLst/>
           </a:prstGeom>
           <a:solidFill>
-            <a:srgbClr val="F0F4F8"/>
+            <a:srgbClr val="F8FAFC"/>
           </a:solidFill>
           <a:ln w="19050">
             <a:solidFill>
-              <a:srgbClr val="B0C4DE"/>
+              <a:srgbClr val="CBD5E1"/>
             </a:solidFill>
             <a:prstDash val="solid"/>
           </a:ln>
@@ -10284,7 +10284,7 @@
                   <a:srgbClr val="64748B"/>
                 </a:solidFill>
               </a:rPr>
-              <a:t>H1 2026 BASELINE</a:t>
+              <a:t>2025 MO. BASELINE</a:t>
             </a:r>
             <a:endParaRPr lang="en-US" sz="850" dirty="0"/>
           </a:p>
@@ -10317,10 +10317,10 @@
             <a:r>
               <a:rPr lang="en-US" sz="1300" b="1" dirty="0">
                 <a:solidFill>
-                  <a:srgbClr val="1B365D"/>
+                  <a:srgbClr val="64748B"/>
                 </a:solidFill>
               </a:rPr>
-              <a:t>138,315</a:t>
+              <a:t>103,385</a:t>
             </a:r>
             <a:endParaRPr lang="en-US" sz="1300" dirty="0"/>
           </a:p>
@@ -10356,7 +10356,7 @@
                   <a:srgbClr val="64748B"/>
                 </a:solidFill>
               </a:rPr>
-              <a:t>National Monthly Avg</a:t>
+              <a:t>Full Year Baseline (Cans/Mo)</a:t>
             </a:r>
             <a:endParaRPr lang="en-US" sz="800" dirty="0"/>
           </a:p>
@@ -10377,11 +10377,11 @@
             <a:avLst/>
           </a:prstGeom>
           <a:solidFill>
-            <a:srgbClr val="ECFDF5"/>
+            <a:srgbClr val="F0F4F8"/>
           </a:solidFill>
           <a:ln w="19050">
             <a:solidFill>
-              <a:srgbClr val="10B981"/>
+              <a:srgbClr val="B0C4DE"/>
             </a:solidFill>
             <a:prstDash val="solid"/>
           </a:ln>
@@ -10417,7 +10417,7 @@
                   <a:srgbClr val="64748B"/>
                 </a:solidFill>
               </a:rPr>
-              <a:t>Q3 2026 RUN-RATE</a:t>
+              <a:t>H1 2026 BASELINE</a:t>
             </a:r>
             <a:endParaRPr lang="en-US" sz="850" dirty="0"/>
           </a:p>
@@ -10450,10 +10450,10 @@
             <a:r>
               <a:rPr lang="en-US" sz="1300" b="1" dirty="0">
                 <a:solidFill>
-                  <a:srgbClr val="065F46"/>
+                  <a:srgbClr val="1B365D"/>
                 </a:solidFill>
               </a:rPr>
-              <a:t>156,126</a:t>
+              <a:t>138,315</a:t>
             </a:r>
             <a:endParaRPr lang="en-US" sz="1300" dirty="0"/>
           </a:p>
@@ -10489,7 +10489,7 @@
                   <a:srgbClr val="64748B"/>
                 </a:solidFill>
               </a:rPr>
-              <a:t>+12.9% (+17,811 cans/mo)</a:t>
+              <a:t>+33.8% over 2025 baseline</a:t>
             </a:r>
             <a:endParaRPr lang="en-US" sz="800" dirty="0"/>
           </a:p>
@@ -10510,11 +10510,11 @@
             <a:avLst/>
           </a:prstGeom>
           <a:solidFill>
-            <a:srgbClr val="EFF6FF"/>
+            <a:srgbClr val="ECFDF5"/>
           </a:solidFill>
           <a:ln w="19050">
             <a:solidFill>
-              <a:srgbClr val="3B82F6"/>
+              <a:srgbClr val="10B981"/>
             </a:solidFill>
             <a:prstDash val="solid"/>
           </a:ln>
@@ -10550,7 +10550,7 @@
                   <a:srgbClr val="64748B"/>
                 </a:solidFill>
               </a:rPr>
-              <a:t>TOP ACCELERATOR REP</a:t>
+              <a:t>Q3 2026 RUN-RATE</a:t>
             </a:r>
             <a:endParaRPr lang="en-US" sz="850" dirty="0"/>
           </a:p>
@@ -10583,10 +10583,10 @@
             <a:r>
               <a:rPr lang="en-US" sz="1300" b="1" dirty="0">
                 <a:solidFill>
-                  <a:srgbClr val="1E40AF"/>
+                  <a:srgbClr val="065F46"/>
                 </a:solidFill>
               </a:rPr>
-              <a:t>Cairo (+58.7%)</a:t>
+              <a:t>156,126</a:t>
             </a:r>
             <a:endParaRPr lang="en-US" sz="1300" dirty="0"/>
           </a:p>
@@ -10622,7 +10622,7 @@
                   <a:srgbClr val="64748B"/>
                 </a:solidFill>
               </a:rPr>
-              <a:t>Noher Adel: 8,758 → 13,898</a:t>
+              <a:t>+12.9% vs H1 | +51.0% vs '25</a:t>
             </a:r>
             <a:endParaRPr lang="en-US" sz="800" dirty="0"/>
           </a:p>
@@ -10683,7 +10683,7 @@
                   <a:srgbClr val="64748B"/>
                 </a:solidFill>
               </a:rPr>
-              <a:t>NATIONAL VOLUME LEADER</a:t>
+              <a:t>TOP ACCELERATOR REP</a:t>
             </a:r>
             <a:endParaRPr lang="en-US" sz="850" dirty="0"/>
           </a:p>
@@ -10719,7 +10719,7 @@
                   <a:srgbClr val="5B21B6"/>
                 </a:solidFill>
               </a:rPr>
-              <a:t>UE II (25,694/mo)</a:t>
+              <a:t>Cairo (+58.7% vs H1)</a:t>
             </a:r>
             <a:endParaRPr lang="en-US" sz="1300" dirty="0"/>
           </a:p>
@@ -10755,7 +10755,7 @@
                   <a:srgbClr val="64748B"/>
                 </a:solidFill>
               </a:rPr>
-              <a:t>Beshoy Youhanna (+15.2%)</a:t>
+              <a:t>Noher Adel: +94.3% vs '25</a:t>
             </a:r>
             <a:endParaRPr lang="en-US" sz="800" dirty="0"/>
           </a:p>
@@ -10777,21 +10777,22 @@
         </p:nvGraphicFramePr>
         <p:xfrm>
           <a:off x="457200" y="2103120"/>
-          <a:ext cx="6675120" cy="4389120"/>
+          <a:ext cx="6766560" cy="4389120"/>
         </p:xfrm>
         <a:graphic>
           <a:graphicData uri="http://schemas.openxmlformats.org/drawingml/2006/table">
             <a:tbl>
               <a:tblPr/>
               <a:tblGrid>
-                <a:gridCol w="457200"/>
-                <a:gridCol w="1097280"/>
-                <a:gridCol w="1097280"/>
-                <a:gridCol w="731520"/>
-                <a:gridCol w="731520"/>
-                <a:gridCol w="731520"/>
-                <a:gridCol w="731520"/>
-                <a:gridCol w="1097280"/>
+                <a:gridCol w="411480"/>
+                <a:gridCol w="1005840"/>
+                <a:gridCol w="1051560"/>
+                <a:gridCol w="685800"/>
+                <a:gridCol w="685800"/>
+                <a:gridCol w="685800"/>
+                <a:gridCol w="685800"/>
+                <a:gridCol w="685800"/>
+                <a:gridCol w="914400"/>
               </a:tblGrid>
               <a:tr h="399011">
                 <a:tc>
@@ -10991,7 +10992,7 @@
                             <a:srgbClr val="FFFFFF"/>
                           </a:solidFill>
                         </a:rPr>
-                        <a:t>H1 MoAvg</a:t>
+                        <a:t>2025 Mo</a:t>
                       </a:r>
                       <a:endParaRPr lang="en-US" sz="1200" dirty="0"/>
                     </a:p>
@@ -11052,7 +11053,7 @@
                             <a:srgbClr val="FFFFFF"/>
                           </a:solidFill>
                         </a:rPr>
-                        <a:t>Q3 MoAvg</a:t>
+                        <a:t>H1 2026</a:t>
                       </a:r>
                       <a:endParaRPr lang="en-US" sz="1200" dirty="0"/>
                     </a:p>
@@ -11113,7 +11114,7 @@
                             <a:srgbClr val="FFFFFF"/>
                           </a:solidFill>
                         </a:rPr>
-                        <a:t>Diff / Mo</a:t>
+                        <a:t>Q3 2026</a:t>
                       </a:r>
                       <a:endParaRPr lang="en-US" sz="1200" dirty="0"/>
                     </a:p>
@@ -11174,7 +11175,7 @@
                             <a:srgbClr val="FFFFFF"/>
                           </a:solidFill>
                         </a:rPr>
-                        <a:t>Velocity %</a:t>
+                        <a:t>Q3 vs H1</a:t>
                       </a:r>
                       <a:endParaRPr lang="en-US" sz="1200" dirty="0"/>
                     </a:p>
@@ -11235,7 +11236,7 @@
                             <a:srgbClr val="FFFFFF"/>
                           </a:solidFill>
                         </a:rPr>
-                        <a:t>Performance Tier</a:t>
+                        <a:t>Q3 vs '25</a:t>
                       </a:r>
                       <a:endParaRPr lang="en-US" sz="1200" dirty="0"/>
                     </a:p>
@@ -11282,6 +11283,67 @@
                     </a:solidFill>
                   </a:tcPr>
                 </a:tc>
+                <a:tc>
+                  <a:txBody>
+                    <a:bodyPr/>
+                    <a:lstStyle/>
+                    <a:p>
+                      <a:pPr algn="ctr" indent="0" marL="0">
+                        <a:buNone/>
+                      </a:pPr>
+                      <a:r>
+                        <a:rPr lang="en-US" sz="1200" b="1" dirty="0">
+                          <a:solidFill>
+                            <a:srgbClr val="FFFFFF"/>
+                          </a:solidFill>
+                        </a:rPr>
+                        <a:t>Velocity Tier</a:t>
+                      </a:r>
+                      <a:endParaRPr lang="en-US" sz="1200" dirty="0"/>
+                    </a:p>
+                  </a:txBody>
+                  <a:tcPr marL="91440" marR="91440" marT="45720" marB="45720" anchor="ctr">
+                    <a:lnL w="12700" cap="flat" cmpd="sng" algn="ctr">
+                      <a:solidFill>
+                        <a:srgbClr val="E2E8F0"/>
+                      </a:solidFill>
+                      <a:prstDash val="solid"/>
+                      <a:round/>
+                      <a:headEnd type="none" w="med" len="med"/>
+                      <a:tailEnd type="none" w="med" len="med"/>
+                    </a:lnL>
+                    <a:lnR w="12700" cap="flat" cmpd="sng" algn="ctr">
+                      <a:solidFill>
+                        <a:srgbClr val="E2E8F0"/>
+                      </a:solidFill>
+                      <a:prstDash val="solid"/>
+                      <a:round/>
+                      <a:headEnd type="none" w="med" len="med"/>
+                      <a:tailEnd type="none" w="med" len="med"/>
+                    </a:lnR>
+                    <a:lnT w="12700" cap="flat" cmpd="sng" algn="ctr">
+                      <a:solidFill>
+                        <a:srgbClr val="E2E8F0"/>
+                      </a:solidFill>
+                      <a:prstDash val="solid"/>
+                      <a:round/>
+                      <a:headEnd type="none" w="med" len="med"/>
+                      <a:tailEnd type="none" w="med" len="med"/>
+                    </a:lnT>
+                    <a:lnB w="12700" cap="flat" cmpd="sng" algn="ctr">
+                      <a:solidFill>
+                        <a:srgbClr val="E2E8F0"/>
+                      </a:solidFill>
+                      <a:prstDash val="solid"/>
+                      <a:round/>
+                      <a:headEnd type="none" w="med" len="med"/>
+                      <a:tailEnd type="none" w="med" len="med"/>
+                    </a:lnB>
+                    <a:solidFill>
+                      <a:srgbClr val="1B365D"/>
+                    </a:solidFill>
+                  </a:tcPr>
+                </a:tc>
               </a:tr>
               <a:tr h="399011">
                 <a:tc>
@@ -11481,7 +11543,7 @@
                             <a:srgbClr val="000000"/>
                           </a:solidFill>
                         </a:rPr>
-                        <a:t>138,315</a:t>
+                        <a:t>103,385</a:t>
                       </a:r>
                       <a:endParaRPr lang="en-US" sz="1200" dirty="0"/>
                     </a:p>
@@ -11542,7 +11604,7 @@
                             <a:srgbClr val="000000"/>
                           </a:solidFill>
                         </a:rPr>
-                        <a:t>156,126</a:t>
+                        <a:t>138,315</a:t>
                       </a:r>
                       <a:endParaRPr lang="en-US" sz="1200" dirty="0"/>
                     </a:p>
@@ -11600,10 +11662,10 @@
                       <a:r>
                         <a:rPr lang="en-US" sz="1200" b="1" dirty="0">
                           <a:solidFill>
-                            <a:srgbClr val="000000"/>
-                          </a:solidFill>
-                        </a:rPr>
-                        <a:t>+17,811</a:t>
+                            <a:srgbClr val="8B5CF6"/>
+                          </a:solidFill>
+                        </a:rPr>
+                        <a:t>156,126</a:t>
                       </a:r>
                       <a:endParaRPr lang="en-US" sz="1200" dirty="0"/>
                     </a:p>
@@ -11722,10 +11784,10 @@
                       <a:r>
                         <a:rPr lang="en-US" sz="1200" b="1" dirty="0">
                           <a:solidFill>
-                            <a:srgbClr val="1B365D"/>
-                          </a:solidFill>
-                        </a:rPr>
-                        <a:t>NATIONAL BENCHMARK</a:t>
+                            <a:srgbClr val="28A745"/>
+                          </a:solidFill>
+                        </a:rPr>
+                        <a:t>+51.0%</a:t>
                       </a:r>
                       <a:endParaRPr lang="en-US" sz="1200" dirty="0"/>
                     </a:p>
@@ -11772,6 +11834,67 @@
                     </a:solidFill>
                   </a:tcPr>
                 </a:tc>
+                <a:tc>
+                  <a:txBody>
+                    <a:bodyPr/>
+                    <a:lstStyle/>
+                    <a:p>
+                      <a:pPr algn="ctr" indent="0" marL="0">
+                        <a:buNone/>
+                      </a:pPr>
+                      <a:r>
+                        <a:rPr lang="en-US" sz="1200" b="1" dirty="0">
+                          <a:solidFill>
+                            <a:srgbClr val="1B365D"/>
+                          </a:solidFill>
+                        </a:rPr>
+                        <a:t>NATIONAL BENCHMARK</a:t>
+                      </a:r>
+                      <a:endParaRPr lang="en-US" sz="1200" dirty="0"/>
+                    </a:p>
+                  </a:txBody>
+                  <a:tcPr marL="91440" marR="91440" marT="45720" marB="45720" anchor="ctr">
+                    <a:lnL w="12700" cap="flat" cmpd="sng" algn="ctr">
+                      <a:solidFill>
+                        <a:srgbClr val="E2E8F0"/>
+                      </a:solidFill>
+                      <a:prstDash val="solid"/>
+                      <a:round/>
+                      <a:headEnd type="none" w="med" len="med"/>
+                      <a:tailEnd type="none" w="med" len="med"/>
+                    </a:lnL>
+                    <a:lnR w="12700" cap="flat" cmpd="sng" algn="ctr">
+                      <a:solidFill>
+                        <a:srgbClr val="E2E8F0"/>
+                      </a:solidFill>
+                      <a:prstDash val="solid"/>
+                      <a:round/>
+                      <a:headEnd type="none" w="med" len="med"/>
+                      <a:tailEnd type="none" w="med" len="med"/>
+                    </a:lnR>
+                    <a:lnT w="12700" cap="flat" cmpd="sng" algn="ctr">
+                      <a:solidFill>
+                        <a:srgbClr val="E2E8F0"/>
+                      </a:solidFill>
+                      <a:prstDash val="solid"/>
+                      <a:round/>
+                      <a:headEnd type="none" w="med" len="med"/>
+                      <a:tailEnd type="none" w="med" len="med"/>
+                    </a:lnT>
+                    <a:lnB w="12700" cap="flat" cmpd="sng" algn="ctr">
+                      <a:solidFill>
+                        <a:srgbClr val="E2E8F0"/>
+                      </a:solidFill>
+                      <a:prstDash val="solid"/>
+                      <a:round/>
+                      <a:headEnd type="none" w="med" len="med"/>
+                      <a:tailEnd type="none" w="med" len="med"/>
+                    </a:lnB>
+                    <a:solidFill>
+                      <a:srgbClr val="E8EEF5"/>
+                    </a:solidFill>
+                  </a:tcPr>
+                </a:tc>
               </a:tr>
               <a:tr h="399011">
                 <a:tc>
@@ -11962,6 +12085,64 @@
                             <a:srgbClr val="000000"/>
                           </a:solidFill>
                         </a:rPr>
+                        <a:t>7,152</a:t>
+                      </a:r>
+                      <a:endParaRPr lang="en-US" sz="800" dirty="0"/>
+                    </a:p>
+                  </a:txBody>
+                  <a:tcPr marL="91440" marR="91440" marT="45720" marB="45720" anchor="ctr">
+                    <a:lnL w="12700" cap="flat" cmpd="sng" algn="ctr">
+                      <a:solidFill>
+                        <a:srgbClr val="E2E8F0"/>
+                      </a:solidFill>
+                      <a:prstDash val="solid"/>
+                      <a:round/>
+                      <a:headEnd type="none" w="med" len="med"/>
+                      <a:tailEnd type="none" w="med" len="med"/>
+                    </a:lnL>
+                    <a:lnR w="12700" cap="flat" cmpd="sng" algn="ctr">
+                      <a:solidFill>
+                        <a:srgbClr val="E2E8F0"/>
+                      </a:solidFill>
+                      <a:prstDash val="solid"/>
+                      <a:round/>
+                      <a:headEnd type="none" w="med" len="med"/>
+                      <a:tailEnd type="none" w="med" len="med"/>
+                    </a:lnR>
+                    <a:lnT w="12700" cap="flat" cmpd="sng" algn="ctr">
+                      <a:solidFill>
+                        <a:srgbClr val="E2E8F0"/>
+                      </a:solidFill>
+                      <a:prstDash val="solid"/>
+                      <a:round/>
+                      <a:headEnd type="none" w="med" len="med"/>
+                      <a:tailEnd type="none" w="med" len="med"/>
+                    </a:lnT>
+                    <a:lnB w="12700" cap="flat" cmpd="sng" algn="ctr">
+                      <a:solidFill>
+                        <a:srgbClr val="E2E8F0"/>
+                      </a:solidFill>
+                      <a:prstDash val="solid"/>
+                      <a:round/>
+                      <a:headEnd type="none" w="med" len="med"/>
+                      <a:tailEnd type="none" w="med" len="med"/>
+                    </a:lnB>
+                  </a:tcPr>
+                </a:tc>
+                <a:tc>
+                  <a:txBody>
+                    <a:bodyPr/>
+                    <a:lstStyle/>
+                    <a:p>
+                      <a:pPr algn="ctr" indent="0" marL="0">
+                        <a:buNone/>
+                      </a:pPr>
+                      <a:r>
+                        <a:rPr lang="en-US" sz="800" dirty="0">
+                          <a:solidFill>
+                            <a:srgbClr val="000000"/>
+                          </a:solidFill>
+                        </a:rPr>
                         <a:t>8,758</a:t>
                       </a:r>
                       <a:endParaRPr lang="en-US" sz="800" dirty="0"/>
@@ -12017,7 +12198,7 @@
                       <a:r>
                         <a:rPr lang="en-US" sz="800" b="1" dirty="0">
                           <a:solidFill>
-                            <a:srgbClr val="000000"/>
+                            <a:srgbClr val="8B5CF6"/>
                           </a:solidFill>
                         </a:rPr>
                         <a:t>13,898</a:t>
@@ -12073,14 +12254,14 @@
                         <a:buNone/>
                       </a:pPr>
                       <a:r>
-                        <a:rPr lang="en-US" sz="800" dirty="0">
+                        <a:rPr lang="en-US" sz="850" b="1" dirty="0">
                           <a:solidFill>
                             <a:srgbClr val="28A745"/>
                           </a:solidFill>
                         </a:rPr>
-                        <a:t>+5,140</a:t>
-                      </a:r>
-                      <a:endParaRPr lang="en-US" sz="800" dirty="0"/>
+                        <a:t>+58.7%</a:t>
+                      </a:r>
+                      <a:endParaRPr lang="en-US" sz="850" dirty="0"/>
                     </a:p>
                   </a:txBody>
                   <a:tcPr marL="91440" marR="91440" marT="45720" marB="45720" anchor="ctr">
@@ -12136,7 +12317,7 @@
                             <a:srgbClr val="28A745"/>
                           </a:solidFill>
                         </a:rPr>
-                        <a:t>+58.7%</a:t>
+                        <a:t>+94.3%</a:t>
                       </a:r>
                       <a:endParaRPr lang="en-US" sz="850" dirty="0"/>
                     </a:p>
@@ -12428,6 +12609,64 @@
                             <a:srgbClr val="000000"/>
                           </a:solidFill>
                         </a:rPr>
+                        <a:t>9,337</a:t>
+                      </a:r>
+                      <a:endParaRPr lang="en-US" sz="800" dirty="0"/>
+                    </a:p>
+                  </a:txBody>
+                  <a:tcPr marL="91440" marR="91440" marT="45720" marB="45720" anchor="ctr">
+                    <a:lnL w="12700" cap="flat" cmpd="sng" algn="ctr">
+                      <a:solidFill>
+                        <a:srgbClr val="E2E8F0"/>
+                      </a:solidFill>
+                      <a:prstDash val="solid"/>
+                      <a:round/>
+                      <a:headEnd type="none" w="med" len="med"/>
+                      <a:tailEnd type="none" w="med" len="med"/>
+                    </a:lnL>
+                    <a:lnR w="12700" cap="flat" cmpd="sng" algn="ctr">
+                      <a:solidFill>
+                        <a:srgbClr val="E2E8F0"/>
+                      </a:solidFill>
+                      <a:prstDash val="solid"/>
+                      <a:round/>
+                      <a:headEnd type="none" w="med" len="med"/>
+                      <a:tailEnd type="none" w="med" len="med"/>
+                    </a:lnR>
+                    <a:lnT w="12700" cap="flat" cmpd="sng" algn="ctr">
+                      <a:solidFill>
+                        <a:srgbClr val="E2E8F0"/>
+                      </a:solidFill>
+                      <a:prstDash val="solid"/>
+                      <a:round/>
+                      <a:headEnd type="none" w="med" len="med"/>
+                      <a:tailEnd type="none" w="med" len="med"/>
+                    </a:lnT>
+                    <a:lnB w="12700" cap="flat" cmpd="sng" algn="ctr">
+                      <a:solidFill>
+                        <a:srgbClr val="E2E8F0"/>
+                      </a:solidFill>
+                      <a:prstDash val="solid"/>
+                      <a:round/>
+                      <a:headEnd type="none" w="med" len="med"/>
+                      <a:tailEnd type="none" w="med" len="med"/>
+                    </a:lnB>
+                  </a:tcPr>
+                </a:tc>
+                <a:tc>
+                  <a:txBody>
+                    <a:bodyPr/>
+                    <a:lstStyle/>
+                    <a:p>
+                      <a:pPr algn="ctr" indent="0" marL="0">
+                        <a:buNone/>
+                      </a:pPr>
+                      <a:r>
+                        <a:rPr lang="en-US" sz="800" dirty="0">
+                          <a:solidFill>
+                            <a:srgbClr val="000000"/>
+                          </a:solidFill>
+                        </a:rPr>
                         <a:t>10,461</a:t>
                       </a:r>
                       <a:endParaRPr lang="en-US" sz="800" dirty="0"/>
@@ -12483,7 +12722,7 @@
                       <a:r>
                         <a:rPr lang="en-US" sz="800" b="1" dirty="0">
                           <a:solidFill>
-                            <a:srgbClr val="000000"/>
+                            <a:srgbClr val="8B5CF6"/>
                           </a:solidFill>
                         </a:rPr>
                         <a:t>15,472</a:t>
@@ -12539,14 +12778,14 @@
                         <a:buNone/>
                       </a:pPr>
                       <a:r>
-                        <a:rPr lang="en-US" sz="800" dirty="0">
+                        <a:rPr lang="en-US" sz="850" b="1" dirty="0">
                           <a:solidFill>
                             <a:srgbClr val="28A745"/>
                           </a:solidFill>
                         </a:rPr>
-                        <a:t>+5,011</a:t>
-                      </a:r>
-                      <a:endParaRPr lang="en-US" sz="800" dirty="0"/>
+                        <a:t>+47.9%</a:t>
+                      </a:r>
+                      <a:endParaRPr lang="en-US" sz="850" dirty="0"/>
                     </a:p>
                   </a:txBody>
                   <a:tcPr marL="91440" marR="91440" marT="45720" marB="45720" anchor="ctr">
@@ -12602,7 +12841,7 @@
                             <a:srgbClr val="28A745"/>
                           </a:solidFill>
                         </a:rPr>
-                        <a:t>+47.9%</a:t>
+                        <a:t>+65.7%</a:t>
                       </a:r>
                       <a:endParaRPr lang="en-US" sz="850" dirty="0"/>
                     </a:p>
@@ -12894,6 +13133,64 @@
                             <a:srgbClr val="000000"/>
                           </a:solidFill>
                         </a:rPr>
+                        <a:t>12,877</a:t>
+                      </a:r>
+                      <a:endParaRPr lang="en-US" sz="800" dirty="0"/>
+                    </a:p>
+                  </a:txBody>
+                  <a:tcPr marL="91440" marR="91440" marT="45720" marB="45720" anchor="ctr">
+                    <a:lnL w="12700" cap="flat" cmpd="sng" algn="ctr">
+                      <a:solidFill>
+                        <a:srgbClr val="E2E8F0"/>
+                      </a:solidFill>
+                      <a:prstDash val="solid"/>
+                      <a:round/>
+                      <a:headEnd type="none" w="med" len="med"/>
+                      <a:tailEnd type="none" w="med" len="med"/>
+                    </a:lnL>
+                    <a:lnR w="12700" cap="flat" cmpd="sng" algn="ctr">
+                      <a:solidFill>
+                        <a:srgbClr val="E2E8F0"/>
+                      </a:solidFill>
+                      <a:prstDash val="solid"/>
+                      <a:round/>
+                      <a:headEnd type="none" w="med" len="med"/>
+                      <a:tailEnd type="none" w="med" len="med"/>
+                    </a:lnR>
+                    <a:lnT w="12700" cap="flat" cmpd="sng" algn="ctr">
+                      <a:solidFill>
+                        <a:srgbClr val="E2E8F0"/>
+                      </a:solidFill>
+                      <a:prstDash val="solid"/>
+                      <a:round/>
+                      <a:headEnd type="none" w="med" len="med"/>
+                      <a:tailEnd type="none" w="med" len="med"/>
+                    </a:lnT>
+                    <a:lnB w="12700" cap="flat" cmpd="sng" algn="ctr">
+                      <a:solidFill>
+                        <a:srgbClr val="E2E8F0"/>
+                      </a:solidFill>
+                      <a:prstDash val="solid"/>
+                      <a:round/>
+                      <a:headEnd type="none" w="med" len="med"/>
+                      <a:tailEnd type="none" w="med" len="med"/>
+                    </a:lnB>
+                  </a:tcPr>
+                </a:tc>
+                <a:tc>
+                  <a:txBody>
+                    <a:bodyPr/>
+                    <a:lstStyle/>
+                    <a:p>
+                      <a:pPr algn="ctr" indent="0" marL="0">
+                        <a:buNone/>
+                      </a:pPr>
+                      <a:r>
+                        <a:rPr lang="en-US" sz="800" dirty="0">
+                          <a:solidFill>
+                            <a:srgbClr val="000000"/>
+                          </a:solidFill>
+                        </a:rPr>
                         <a:t>16,459</a:t>
                       </a:r>
                       <a:endParaRPr lang="en-US" sz="800" dirty="0"/>
@@ -12949,7 +13246,7 @@
                       <a:r>
                         <a:rPr lang="en-US" sz="800" b="1" dirty="0">
                           <a:solidFill>
-                            <a:srgbClr val="000000"/>
+                            <a:srgbClr val="8B5CF6"/>
                           </a:solidFill>
                         </a:rPr>
                         <a:t>23,564</a:t>
@@ -13005,14 +13302,14 @@
                         <a:buNone/>
                       </a:pPr>
                       <a:r>
-                        <a:rPr lang="en-US" sz="800" dirty="0">
+                        <a:rPr lang="en-US" sz="850" b="1" dirty="0">
                           <a:solidFill>
                             <a:srgbClr val="28A745"/>
                           </a:solidFill>
                         </a:rPr>
-                        <a:t>+7,105</a:t>
-                      </a:r>
-                      <a:endParaRPr lang="en-US" sz="800" dirty="0"/>
+                        <a:t>+43.2%</a:t>
+                      </a:r>
+                      <a:endParaRPr lang="en-US" sz="850" dirty="0"/>
                     </a:p>
                   </a:txBody>
                   <a:tcPr marL="91440" marR="91440" marT="45720" marB="45720" anchor="ctr">
@@ -13068,7 +13365,7 @@
                             <a:srgbClr val="28A745"/>
                           </a:solidFill>
                         </a:rPr>
-                        <a:t>+43.2%</a:t>
+                        <a:t>+83.0%</a:t>
                       </a:r>
                       <a:endParaRPr lang="en-US" sz="850" dirty="0"/>
                     </a:p>
@@ -13360,6 +13657,64 @@
                             <a:srgbClr val="000000"/>
                           </a:solidFill>
                         </a:rPr>
+                        <a:t>12,441</a:t>
+                      </a:r>
+                      <a:endParaRPr lang="en-US" sz="800" dirty="0"/>
+                    </a:p>
+                  </a:txBody>
+                  <a:tcPr marL="91440" marR="91440" marT="45720" marB="45720" anchor="ctr">
+                    <a:lnL w="12700" cap="flat" cmpd="sng" algn="ctr">
+                      <a:solidFill>
+                        <a:srgbClr val="E2E8F0"/>
+                      </a:solidFill>
+                      <a:prstDash val="solid"/>
+                      <a:round/>
+                      <a:headEnd type="none" w="med" len="med"/>
+                      <a:tailEnd type="none" w="med" len="med"/>
+                    </a:lnL>
+                    <a:lnR w="12700" cap="flat" cmpd="sng" algn="ctr">
+                      <a:solidFill>
+                        <a:srgbClr val="E2E8F0"/>
+                      </a:solidFill>
+                      <a:prstDash val="solid"/>
+                      <a:round/>
+                      <a:headEnd type="none" w="med" len="med"/>
+                      <a:tailEnd type="none" w="med" len="med"/>
+                    </a:lnR>
+                    <a:lnT w="12700" cap="flat" cmpd="sng" algn="ctr">
+                      <a:solidFill>
+                        <a:srgbClr val="E2E8F0"/>
+                      </a:solidFill>
+                      <a:prstDash val="solid"/>
+                      <a:round/>
+                      <a:headEnd type="none" w="med" len="med"/>
+                      <a:tailEnd type="none" w="med" len="med"/>
+                    </a:lnT>
+                    <a:lnB w="12700" cap="flat" cmpd="sng" algn="ctr">
+                      <a:solidFill>
+                        <a:srgbClr val="E2E8F0"/>
+                      </a:solidFill>
+                      <a:prstDash val="solid"/>
+                      <a:round/>
+                      <a:headEnd type="none" w="med" len="med"/>
+                      <a:tailEnd type="none" w="med" len="med"/>
+                    </a:lnB>
+                  </a:tcPr>
+                </a:tc>
+                <a:tc>
+                  <a:txBody>
+                    <a:bodyPr/>
+                    <a:lstStyle/>
+                    <a:p>
+                      <a:pPr algn="ctr" indent="0" marL="0">
+                        <a:buNone/>
+                      </a:pPr>
+                      <a:r>
+                        <a:rPr lang="en-US" sz="800" dirty="0">
+                          <a:solidFill>
+                            <a:srgbClr val="000000"/>
+                          </a:solidFill>
+                        </a:rPr>
                         <a:t>14,302</a:t>
                       </a:r>
                       <a:endParaRPr lang="en-US" sz="800" dirty="0"/>
@@ -13415,7 +13770,7 @@
                       <a:r>
                         <a:rPr lang="en-US" sz="800" b="1" dirty="0">
                           <a:solidFill>
-                            <a:srgbClr val="000000"/>
+                            <a:srgbClr val="8B5CF6"/>
                           </a:solidFill>
                         </a:rPr>
                         <a:t>18,041</a:t>
@@ -13471,14 +13826,14 @@
                         <a:buNone/>
                       </a:pPr>
                       <a:r>
-                        <a:rPr lang="en-US" sz="800" dirty="0">
+                        <a:rPr lang="en-US" sz="850" b="1" dirty="0">
                           <a:solidFill>
                             <a:srgbClr val="28A745"/>
                           </a:solidFill>
                         </a:rPr>
-                        <a:t>+3,739</a:t>
-                      </a:r>
-                      <a:endParaRPr lang="en-US" sz="800" dirty="0"/>
+                        <a:t>+26.1%</a:t>
+                      </a:r>
+                      <a:endParaRPr lang="en-US" sz="850" dirty="0"/>
                     </a:p>
                   </a:txBody>
                   <a:tcPr marL="91440" marR="91440" marT="45720" marB="45720" anchor="ctr">
@@ -13531,10 +13886,10 @@
                       <a:r>
                         <a:rPr lang="en-US" sz="850" b="1" dirty="0">
                           <a:solidFill>
-                            <a:srgbClr val="28A745"/>
-                          </a:solidFill>
-                        </a:rPr>
-                        <a:t>+26.1%</a:t>
+                            <a:srgbClr val="1B365D"/>
+                          </a:solidFill>
+                        </a:rPr>
+                        <a:t>+45.0%</a:t>
                       </a:r>
                       <a:endParaRPr lang="en-US" sz="850" dirty="0"/>
                     </a:p>
@@ -13826,6 +14181,64 @@
                             <a:srgbClr val="000000"/>
                           </a:solidFill>
                         </a:rPr>
+                        <a:t>14,859</a:t>
+                      </a:r>
+                      <a:endParaRPr lang="en-US" sz="800" dirty="0"/>
+                    </a:p>
+                  </a:txBody>
+                  <a:tcPr marL="91440" marR="91440" marT="45720" marB="45720" anchor="ctr">
+                    <a:lnL w="12700" cap="flat" cmpd="sng" algn="ctr">
+                      <a:solidFill>
+                        <a:srgbClr val="E2E8F0"/>
+                      </a:solidFill>
+                      <a:prstDash val="solid"/>
+                      <a:round/>
+                      <a:headEnd type="none" w="med" len="med"/>
+                      <a:tailEnd type="none" w="med" len="med"/>
+                    </a:lnL>
+                    <a:lnR w="12700" cap="flat" cmpd="sng" algn="ctr">
+                      <a:solidFill>
+                        <a:srgbClr val="E2E8F0"/>
+                      </a:solidFill>
+                      <a:prstDash val="solid"/>
+                      <a:round/>
+                      <a:headEnd type="none" w="med" len="med"/>
+                      <a:tailEnd type="none" w="med" len="med"/>
+                    </a:lnR>
+                    <a:lnT w="12700" cap="flat" cmpd="sng" algn="ctr">
+                      <a:solidFill>
+                        <a:srgbClr val="E2E8F0"/>
+                      </a:solidFill>
+                      <a:prstDash val="solid"/>
+                      <a:round/>
+                      <a:headEnd type="none" w="med" len="med"/>
+                      <a:tailEnd type="none" w="med" len="med"/>
+                    </a:lnT>
+                    <a:lnB w="12700" cap="flat" cmpd="sng" algn="ctr">
+                      <a:solidFill>
+                        <a:srgbClr val="E2E8F0"/>
+                      </a:solidFill>
+                      <a:prstDash val="solid"/>
+                      <a:round/>
+                      <a:headEnd type="none" w="med" len="med"/>
+                      <a:tailEnd type="none" w="med" len="med"/>
+                    </a:lnB>
+                  </a:tcPr>
+                </a:tc>
+                <a:tc>
+                  <a:txBody>
+                    <a:bodyPr/>
+                    <a:lstStyle/>
+                    <a:p>
+                      <a:pPr algn="ctr" indent="0" marL="0">
+                        <a:buNone/>
+                      </a:pPr>
+                      <a:r>
+                        <a:rPr lang="en-US" sz="800" dirty="0">
+                          <a:solidFill>
+                            <a:srgbClr val="000000"/>
+                          </a:solidFill>
+                        </a:rPr>
                         <a:t>22,305</a:t>
                       </a:r>
                       <a:endParaRPr lang="en-US" sz="800" dirty="0"/>
@@ -13881,7 +14294,7 @@
                       <a:r>
                         <a:rPr lang="en-US" sz="800" b="1" dirty="0">
                           <a:solidFill>
-                            <a:srgbClr val="000000"/>
+                            <a:srgbClr val="8B5CF6"/>
                           </a:solidFill>
                         </a:rPr>
                         <a:t>25,694</a:t>
@@ -13937,14 +14350,14 @@
                         <a:buNone/>
                       </a:pPr>
                       <a:r>
-                        <a:rPr lang="en-US" sz="800" dirty="0">
+                        <a:rPr lang="en-US" sz="850" b="1" dirty="0">
                           <a:solidFill>
                             <a:srgbClr val="28A745"/>
                           </a:solidFill>
                         </a:rPr>
-                        <a:t>+3,389</a:t>
-                      </a:r>
-                      <a:endParaRPr lang="en-US" sz="800" dirty="0"/>
+                        <a:t>+15.2%</a:t>
+                      </a:r>
+                      <a:endParaRPr lang="en-US" sz="850" dirty="0"/>
                     </a:p>
                   </a:txBody>
                   <a:tcPr marL="91440" marR="91440" marT="45720" marB="45720" anchor="ctr">
@@ -14000,7 +14413,7 @@
                             <a:srgbClr val="28A745"/>
                           </a:solidFill>
                         </a:rPr>
-                        <a:t>+15.2%</a:t>
+                        <a:t>+72.9%</a:t>
                       </a:r>
                       <a:endParaRPr lang="en-US" sz="850" dirty="0"/>
                     </a:p>
@@ -14292,6 +14705,64 @@
                             <a:srgbClr val="000000"/>
                           </a:solidFill>
                         </a:rPr>
+                        <a:t>9,951</a:t>
+                      </a:r>
+                      <a:endParaRPr lang="en-US" sz="800" dirty="0"/>
+                    </a:p>
+                  </a:txBody>
+                  <a:tcPr marL="91440" marR="91440" marT="45720" marB="45720" anchor="ctr">
+                    <a:lnL w="12700" cap="flat" cmpd="sng" algn="ctr">
+                      <a:solidFill>
+                        <a:srgbClr val="E2E8F0"/>
+                      </a:solidFill>
+                      <a:prstDash val="solid"/>
+                      <a:round/>
+                      <a:headEnd type="none" w="med" len="med"/>
+                      <a:tailEnd type="none" w="med" len="med"/>
+                    </a:lnL>
+                    <a:lnR w="12700" cap="flat" cmpd="sng" algn="ctr">
+                      <a:solidFill>
+                        <a:srgbClr val="E2E8F0"/>
+                      </a:solidFill>
+                      <a:prstDash val="solid"/>
+                      <a:round/>
+                      <a:headEnd type="none" w="med" len="med"/>
+                      <a:tailEnd type="none" w="med" len="med"/>
+                    </a:lnR>
+                    <a:lnT w="12700" cap="flat" cmpd="sng" algn="ctr">
+                      <a:solidFill>
+                        <a:srgbClr val="E2E8F0"/>
+                      </a:solidFill>
+                      <a:prstDash val="solid"/>
+                      <a:round/>
+                      <a:headEnd type="none" w="med" len="med"/>
+                      <a:tailEnd type="none" w="med" len="med"/>
+                    </a:lnT>
+                    <a:lnB w="12700" cap="flat" cmpd="sng" algn="ctr">
+                      <a:solidFill>
+                        <a:srgbClr val="E2E8F0"/>
+                      </a:solidFill>
+                      <a:prstDash val="solid"/>
+                      <a:round/>
+                      <a:headEnd type="none" w="med" len="med"/>
+                      <a:tailEnd type="none" w="med" len="med"/>
+                    </a:lnB>
+                  </a:tcPr>
+                </a:tc>
+                <a:tc>
+                  <a:txBody>
+                    <a:bodyPr/>
+                    <a:lstStyle/>
+                    <a:p>
+                      <a:pPr algn="ctr" indent="0" marL="0">
+                        <a:buNone/>
+                      </a:pPr>
+                      <a:r>
+                        <a:rPr lang="en-US" sz="800" dirty="0">
+                          <a:solidFill>
+                            <a:srgbClr val="000000"/>
+                          </a:solidFill>
+                        </a:rPr>
                         <a:t>12,895</a:t>
                       </a:r>
                       <a:endParaRPr lang="en-US" sz="800" dirty="0"/>
@@ -14347,7 +14818,7 @@
                       <a:r>
                         <a:rPr lang="en-US" sz="800" b="1" dirty="0">
                           <a:solidFill>
-                            <a:srgbClr val="000000"/>
+                            <a:srgbClr val="8B5CF6"/>
                           </a:solidFill>
                         </a:rPr>
                         <a:t>13,858</a:t>
@@ -14403,70 +14874,70 @@
                         <a:buNone/>
                       </a:pPr>
                       <a:r>
-                        <a:rPr lang="en-US" sz="800" dirty="0">
-                          <a:solidFill>
-                            <a:srgbClr val="28A745"/>
-                          </a:solidFill>
-                        </a:rPr>
-                        <a:t>+963</a:t>
-                      </a:r>
-                      <a:endParaRPr lang="en-US" sz="800" dirty="0"/>
-                    </a:p>
-                  </a:txBody>
-                  <a:tcPr marL="91440" marR="91440" marT="45720" marB="45720" anchor="ctr">
-                    <a:lnL w="12700" cap="flat" cmpd="sng" algn="ctr">
-                      <a:solidFill>
-                        <a:srgbClr val="E2E8F0"/>
-                      </a:solidFill>
-                      <a:prstDash val="solid"/>
-                      <a:round/>
-                      <a:headEnd type="none" w="med" len="med"/>
-                      <a:tailEnd type="none" w="med" len="med"/>
-                    </a:lnL>
-                    <a:lnR w="12700" cap="flat" cmpd="sng" algn="ctr">
-                      <a:solidFill>
-                        <a:srgbClr val="E2E8F0"/>
-                      </a:solidFill>
-                      <a:prstDash val="solid"/>
-                      <a:round/>
-                      <a:headEnd type="none" w="med" len="med"/>
-                      <a:tailEnd type="none" w="med" len="med"/>
-                    </a:lnR>
-                    <a:lnT w="12700" cap="flat" cmpd="sng" algn="ctr">
-                      <a:solidFill>
-                        <a:srgbClr val="E2E8F0"/>
-                      </a:solidFill>
-                      <a:prstDash val="solid"/>
-                      <a:round/>
-                      <a:headEnd type="none" w="med" len="med"/>
-                      <a:tailEnd type="none" w="med" len="med"/>
-                    </a:lnT>
-                    <a:lnB w="12700" cap="flat" cmpd="sng" algn="ctr">
-                      <a:solidFill>
-                        <a:srgbClr val="E2E8F0"/>
-                      </a:solidFill>
-                      <a:prstDash val="solid"/>
-                      <a:round/>
-                      <a:headEnd type="none" w="med" len="med"/>
-                      <a:tailEnd type="none" w="med" len="med"/>
-                    </a:lnB>
-                  </a:tcPr>
-                </a:tc>
-                <a:tc>
-                  <a:txBody>
-                    <a:bodyPr/>
-                    <a:lstStyle/>
-                    <a:p>
-                      <a:pPr algn="ctr" indent="0" marL="0">
-                        <a:buNone/>
-                      </a:pPr>
-                      <a:r>
                         <a:rPr lang="en-US" sz="850" b="1" dirty="0">
                           <a:solidFill>
                             <a:srgbClr val="B45309"/>
                           </a:solidFill>
                         </a:rPr>
                         <a:t>+7.5%</a:t>
+                      </a:r>
+                      <a:endParaRPr lang="en-US" sz="850" dirty="0"/>
+                    </a:p>
+                  </a:txBody>
+                  <a:tcPr marL="91440" marR="91440" marT="45720" marB="45720" anchor="ctr">
+                    <a:lnL w="12700" cap="flat" cmpd="sng" algn="ctr">
+                      <a:solidFill>
+                        <a:srgbClr val="E2E8F0"/>
+                      </a:solidFill>
+                      <a:prstDash val="solid"/>
+                      <a:round/>
+                      <a:headEnd type="none" w="med" len="med"/>
+                      <a:tailEnd type="none" w="med" len="med"/>
+                    </a:lnL>
+                    <a:lnR w="12700" cap="flat" cmpd="sng" algn="ctr">
+                      <a:solidFill>
+                        <a:srgbClr val="E2E8F0"/>
+                      </a:solidFill>
+                      <a:prstDash val="solid"/>
+                      <a:round/>
+                      <a:headEnd type="none" w="med" len="med"/>
+                      <a:tailEnd type="none" w="med" len="med"/>
+                    </a:lnR>
+                    <a:lnT w="12700" cap="flat" cmpd="sng" algn="ctr">
+                      <a:solidFill>
+                        <a:srgbClr val="E2E8F0"/>
+                      </a:solidFill>
+                      <a:prstDash val="solid"/>
+                      <a:round/>
+                      <a:headEnd type="none" w="med" len="med"/>
+                      <a:tailEnd type="none" w="med" len="med"/>
+                    </a:lnT>
+                    <a:lnB w="12700" cap="flat" cmpd="sng" algn="ctr">
+                      <a:solidFill>
+                        <a:srgbClr val="E2E8F0"/>
+                      </a:solidFill>
+                      <a:prstDash val="solid"/>
+                      <a:round/>
+                      <a:headEnd type="none" w="med" len="med"/>
+                      <a:tailEnd type="none" w="med" len="med"/>
+                    </a:lnB>
+                  </a:tcPr>
+                </a:tc>
+                <a:tc>
+                  <a:txBody>
+                    <a:bodyPr/>
+                    <a:lstStyle/>
+                    <a:p>
+                      <a:pPr algn="ctr" indent="0" marL="0">
+                        <a:buNone/>
+                      </a:pPr>
+                      <a:r>
+                        <a:rPr lang="en-US" sz="850" b="1" dirty="0">
+                          <a:solidFill>
+                            <a:srgbClr val="1B365D"/>
+                          </a:solidFill>
+                        </a:rPr>
+                        <a:t>+39.3%</a:t>
                       </a:r>
                       <a:endParaRPr lang="en-US" sz="850" dirty="0"/>
                     </a:p>
@@ -14758,6 +15229,64 @@
                             <a:srgbClr val="000000"/>
                           </a:solidFill>
                         </a:rPr>
+                        <a:t>7,309</a:t>
+                      </a:r>
+                      <a:endParaRPr lang="en-US" sz="800" dirty="0"/>
+                    </a:p>
+                  </a:txBody>
+                  <a:tcPr marL="91440" marR="91440" marT="45720" marB="45720" anchor="ctr">
+                    <a:lnL w="12700" cap="flat" cmpd="sng" algn="ctr">
+                      <a:solidFill>
+                        <a:srgbClr val="E2E8F0"/>
+                      </a:solidFill>
+                      <a:prstDash val="solid"/>
+                      <a:round/>
+                      <a:headEnd type="none" w="med" len="med"/>
+                      <a:tailEnd type="none" w="med" len="med"/>
+                    </a:lnL>
+                    <a:lnR w="12700" cap="flat" cmpd="sng" algn="ctr">
+                      <a:solidFill>
+                        <a:srgbClr val="E2E8F0"/>
+                      </a:solidFill>
+                      <a:prstDash val="solid"/>
+                      <a:round/>
+                      <a:headEnd type="none" w="med" len="med"/>
+                      <a:tailEnd type="none" w="med" len="med"/>
+                    </a:lnR>
+                    <a:lnT w="12700" cap="flat" cmpd="sng" algn="ctr">
+                      <a:solidFill>
+                        <a:srgbClr val="E2E8F0"/>
+                      </a:solidFill>
+                      <a:prstDash val="solid"/>
+                      <a:round/>
+                      <a:headEnd type="none" w="med" len="med"/>
+                      <a:tailEnd type="none" w="med" len="med"/>
+                    </a:lnT>
+                    <a:lnB w="12700" cap="flat" cmpd="sng" algn="ctr">
+                      <a:solidFill>
+                        <a:srgbClr val="E2E8F0"/>
+                      </a:solidFill>
+                      <a:prstDash val="solid"/>
+                      <a:round/>
+                      <a:headEnd type="none" w="med" len="med"/>
+                      <a:tailEnd type="none" w="med" len="med"/>
+                    </a:lnB>
+                  </a:tcPr>
+                </a:tc>
+                <a:tc>
+                  <a:txBody>
+                    <a:bodyPr/>
+                    <a:lstStyle/>
+                    <a:p>
+                      <a:pPr algn="ctr" indent="0" marL="0">
+                        <a:buNone/>
+                      </a:pPr>
+                      <a:r>
+                        <a:rPr lang="en-US" sz="800" dirty="0">
+                          <a:solidFill>
+                            <a:srgbClr val="000000"/>
+                          </a:solidFill>
+                        </a:rPr>
                         <a:t>10,206</a:t>
                       </a:r>
                       <a:endParaRPr lang="en-US" sz="800" dirty="0"/>
@@ -14813,7 +15342,7 @@
                       <a:r>
                         <a:rPr lang="en-US" sz="800" b="1" dirty="0">
                           <a:solidFill>
-                            <a:srgbClr val="000000"/>
+                            <a:srgbClr val="8B5CF6"/>
                           </a:solidFill>
                         </a:rPr>
                         <a:t>10,314</a:t>
@@ -14869,70 +15398,70 @@
                         <a:buNone/>
                       </a:pPr>
                       <a:r>
-                        <a:rPr lang="en-US" sz="800" dirty="0">
-                          <a:solidFill>
-                            <a:srgbClr val="28A745"/>
-                          </a:solidFill>
-                        </a:rPr>
-                        <a:t>+108</a:t>
-                      </a:r>
-                      <a:endParaRPr lang="en-US" sz="800" dirty="0"/>
-                    </a:p>
-                  </a:txBody>
-                  <a:tcPr marL="91440" marR="91440" marT="45720" marB="45720" anchor="ctr">
-                    <a:lnL w="12700" cap="flat" cmpd="sng" algn="ctr">
-                      <a:solidFill>
-                        <a:srgbClr val="E2E8F0"/>
-                      </a:solidFill>
-                      <a:prstDash val="solid"/>
-                      <a:round/>
-                      <a:headEnd type="none" w="med" len="med"/>
-                      <a:tailEnd type="none" w="med" len="med"/>
-                    </a:lnL>
-                    <a:lnR w="12700" cap="flat" cmpd="sng" algn="ctr">
-                      <a:solidFill>
-                        <a:srgbClr val="E2E8F0"/>
-                      </a:solidFill>
-                      <a:prstDash val="solid"/>
-                      <a:round/>
-                      <a:headEnd type="none" w="med" len="med"/>
-                      <a:tailEnd type="none" w="med" len="med"/>
-                    </a:lnR>
-                    <a:lnT w="12700" cap="flat" cmpd="sng" algn="ctr">
-                      <a:solidFill>
-                        <a:srgbClr val="E2E8F0"/>
-                      </a:solidFill>
-                      <a:prstDash val="solid"/>
-                      <a:round/>
-                      <a:headEnd type="none" w="med" len="med"/>
-                      <a:tailEnd type="none" w="med" len="med"/>
-                    </a:lnT>
-                    <a:lnB w="12700" cap="flat" cmpd="sng" algn="ctr">
-                      <a:solidFill>
-                        <a:srgbClr val="E2E8F0"/>
-                      </a:solidFill>
-                      <a:prstDash val="solid"/>
-                      <a:round/>
-                      <a:headEnd type="none" w="med" len="med"/>
-                      <a:tailEnd type="none" w="med" len="med"/>
-                    </a:lnB>
-                  </a:tcPr>
-                </a:tc>
-                <a:tc>
-                  <a:txBody>
-                    <a:bodyPr/>
-                    <a:lstStyle/>
-                    <a:p>
-                      <a:pPr algn="ctr" indent="0" marL="0">
-                        <a:buNone/>
-                      </a:pPr>
-                      <a:r>
                         <a:rPr lang="en-US" sz="850" b="1" dirty="0">
                           <a:solidFill>
                             <a:srgbClr val="B45309"/>
                           </a:solidFill>
                         </a:rPr>
                         <a:t>+1.1%</a:t>
+                      </a:r>
+                      <a:endParaRPr lang="en-US" sz="850" dirty="0"/>
+                    </a:p>
+                  </a:txBody>
+                  <a:tcPr marL="91440" marR="91440" marT="45720" marB="45720" anchor="ctr">
+                    <a:lnL w="12700" cap="flat" cmpd="sng" algn="ctr">
+                      <a:solidFill>
+                        <a:srgbClr val="E2E8F0"/>
+                      </a:solidFill>
+                      <a:prstDash val="solid"/>
+                      <a:round/>
+                      <a:headEnd type="none" w="med" len="med"/>
+                      <a:tailEnd type="none" w="med" len="med"/>
+                    </a:lnL>
+                    <a:lnR w="12700" cap="flat" cmpd="sng" algn="ctr">
+                      <a:solidFill>
+                        <a:srgbClr val="E2E8F0"/>
+                      </a:solidFill>
+                      <a:prstDash val="solid"/>
+                      <a:round/>
+                      <a:headEnd type="none" w="med" len="med"/>
+                      <a:tailEnd type="none" w="med" len="med"/>
+                    </a:lnR>
+                    <a:lnT w="12700" cap="flat" cmpd="sng" algn="ctr">
+                      <a:solidFill>
+                        <a:srgbClr val="E2E8F0"/>
+                      </a:solidFill>
+                      <a:prstDash val="solid"/>
+                      <a:round/>
+                      <a:headEnd type="none" w="med" len="med"/>
+                      <a:tailEnd type="none" w="med" len="med"/>
+                    </a:lnT>
+                    <a:lnB w="12700" cap="flat" cmpd="sng" algn="ctr">
+                      <a:solidFill>
+                        <a:srgbClr val="E2E8F0"/>
+                      </a:solidFill>
+                      <a:prstDash val="solid"/>
+                      <a:round/>
+                      <a:headEnd type="none" w="med" len="med"/>
+                      <a:tailEnd type="none" w="med" len="med"/>
+                    </a:lnB>
+                  </a:tcPr>
+                </a:tc>
+                <a:tc>
+                  <a:txBody>
+                    <a:bodyPr/>
+                    <a:lstStyle/>
+                    <a:p>
+                      <a:pPr algn="ctr" indent="0" marL="0">
+                        <a:buNone/>
+                      </a:pPr>
+                      <a:r>
+                        <a:rPr lang="en-US" sz="850" b="1" dirty="0">
+                          <a:solidFill>
+                            <a:srgbClr val="1B365D"/>
+                          </a:solidFill>
+                        </a:rPr>
+                        <a:t>+41.1%</a:t>
                       </a:r>
                       <a:endParaRPr lang="en-US" sz="850" dirty="0"/>
                     </a:p>
@@ -15224,6 +15753,64 @@
                             <a:srgbClr val="000000"/>
                           </a:solidFill>
                         </a:rPr>
+                        <a:t>15,235</a:t>
+                      </a:r>
+                      <a:endParaRPr lang="en-US" sz="800" dirty="0"/>
+                    </a:p>
+                  </a:txBody>
+                  <a:tcPr marL="91440" marR="91440" marT="45720" marB="45720" anchor="ctr">
+                    <a:lnL w="12700" cap="flat" cmpd="sng" algn="ctr">
+                      <a:solidFill>
+                        <a:srgbClr val="E2E8F0"/>
+                      </a:solidFill>
+                      <a:prstDash val="solid"/>
+                      <a:round/>
+                      <a:headEnd type="none" w="med" len="med"/>
+                      <a:tailEnd type="none" w="med" len="med"/>
+                    </a:lnL>
+                    <a:lnR w="12700" cap="flat" cmpd="sng" algn="ctr">
+                      <a:solidFill>
+                        <a:srgbClr val="E2E8F0"/>
+                      </a:solidFill>
+                      <a:prstDash val="solid"/>
+                      <a:round/>
+                      <a:headEnd type="none" w="med" len="med"/>
+                      <a:tailEnd type="none" w="med" len="med"/>
+                    </a:lnR>
+                    <a:lnT w="12700" cap="flat" cmpd="sng" algn="ctr">
+                      <a:solidFill>
+                        <a:srgbClr val="E2E8F0"/>
+                      </a:solidFill>
+                      <a:prstDash val="solid"/>
+                      <a:round/>
+                      <a:headEnd type="none" w="med" len="med"/>
+                      <a:tailEnd type="none" w="med" len="med"/>
+                    </a:lnT>
+                    <a:lnB w="12700" cap="flat" cmpd="sng" algn="ctr">
+                      <a:solidFill>
+                        <a:srgbClr val="E2E8F0"/>
+                      </a:solidFill>
+                      <a:prstDash val="solid"/>
+                      <a:round/>
+                      <a:headEnd type="none" w="med" len="med"/>
+                      <a:tailEnd type="none" w="med" len="med"/>
+                    </a:lnB>
+                  </a:tcPr>
+                </a:tc>
+                <a:tc>
+                  <a:txBody>
+                    <a:bodyPr/>
+                    <a:lstStyle/>
+                    <a:p>
+                      <a:pPr algn="ctr" indent="0" marL="0">
+                        <a:buNone/>
+                      </a:pPr>
+                      <a:r>
+                        <a:rPr lang="en-US" sz="800" dirty="0">
+                          <a:solidFill>
+                            <a:srgbClr val="000000"/>
+                          </a:solidFill>
+                        </a:rPr>
                         <a:t>20,146</a:t>
                       </a:r>
                       <a:endParaRPr lang="en-US" sz="800" dirty="0"/>
@@ -15279,7 +15866,7 @@
                       <a:r>
                         <a:rPr lang="en-US" sz="800" b="1" dirty="0">
                           <a:solidFill>
-                            <a:srgbClr val="000000"/>
+                            <a:srgbClr val="8B5CF6"/>
                           </a:solidFill>
                         </a:rPr>
                         <a:t>18,614</a:t>
@@ -15335,14 +15922,14 @@
                         <a:buNone/>
                       </a:pPr>
                       <a:r>
-                        <a:rPr lang="en-US" sz="800" dirty="0">
+                        <a:rPr lang="en-US" sz="850" b="1" dirty="0">
                           <a:solidFill>
                             <a:srgbClr val="DC3545"/>
                           </a:solidFill>
                         </a:rPr>
-                        <a:t>-1,532</a:t>
-                      </a:r>
-                      <a:endParaRPr lang="en-US" sz="800" dirty="0"/>
+                        <a:t>-7.6%</a:t>
+                      </a:r>
+                      <a:endParaRPr lang="en-US" sz="850" dirty="0"/>
                     </a:p>
                   </a:txBody>
                   <a:tcPr marL="91440" marR="91440" marT="45720" marB="45720" anchor="ctr">
@@ -15395,10 +15982,10 @@
                       <a:r>
                         <a:rPr lang="en-US" sz="850" b="1" dirty="0">
                           <a:solidFill>
-                            <a:srgbClr val="DC3545"/>
-                          </a:solidFill>
-                        </a:rPr>
-                        <a:t>-7.6%</a:t>
+                            <a:srgbClr val="1B365D"/>
+                          </a:solidFill>
+                        </a:rPr>
+                        <a:t>+22.2%</a:t>
                       </a:r>
                       <a:endParaRPr lang="en-US" sz="850" dirty="0"/>
                     </a:p>
@@ -15690,6 +16277,64 @@
                             <a:srgbClr val="000000"/>
                           </a:solidFill>
                         </a:rPr>
+                        <a:t>14,224</a:t>
+                      </a:r>
+                      <a:endParaRPr lang="en-US" sz="800" dirty="0"/>
+                    </a:p>
+                  </a:txBody>
+                  <a:tcPr marL="91440" marR="91440" marT="45720" marB="45720" anchor="ctr">
+                    <a:lnL w="12700" cap="flat" cmpd="sng" algn="ctr">
+                      <a:solidFill>
+                        <a:srgbClr val="E2E8F0"/>
+                      </a:solidFill>
+                      <a:prstDash val="solid"/>
+                      <a:round/>
+                      <a:headEnd type="none" w="med" len="med"/>
+                      <a:tailEnd type="none" w="med" len="med"/>
+                    </a:lnL>
+                    <a:lnR w="12700" cap="flat" cmpd="sng" algn="ctr">
+                      <a:solidFill>
+                        <a:srgbClr val="E2E8F0"/>
+                      </a:solidFill>
+                      <a:prstDash val="solid"/>
+                      <a:round/>
+                      <a:headEnd type="none" w="med" len="med"/>
+                      <a:tailEnd type="none" w="med" len="med"/>
+                    </a:lnR>
+                    <a:lnT w="12700" cap="flat" cmpd="sng" algn="ctr">
+                      <a:solidFill>
+                        <a:srgbClr val="E2E8F0"/>
+                      </a:solidFill>
+                      <a:prstDash val="solid"/>
+                      <a:round/>
+                      <a:headEnd type="none" w="med" len="med"/>
+                      <a:tailEnd type="none" w="med" len="med"/>
+                    </a:lnT>
+                    <a:lnB w="12700" cap="flat" cmpd="sng" algn="ctr">
+                      <a:solidFill>
+                        <a:srgbClr val="E2E8F0"/>
+                      </a:solidFill>
+                      <a:prstDash val="solid"/>
+                      <a:round/>
+                      <a:headEnd type="none" w="med" len="med"/>
+                      <a:tailEnd type="none" w="med" len="med"/>
+                    </a:lnB>
+                  </a:tcPr>
+                </a:tc>
+                <a:tc>
+                  <a:txBody>
+                    <a:bodyPr/>
+                    <a:lstStyle/>
+                    <a:p>
+                      <a:pPr algn="ctr" indent="0" marL="0">
+                        <a:buNone/>
+                      </a:pPr>
+                      <a:r>
+                        <a:rPr lang="en-US" sz="800" dirty="0">
+                          <a:solidFill>
+                            <a:srgbClr val="000000"/>
+                          </a:solidFill>
+                        </a:rPr>
                         <a:t>22,783</a:t>
                       </a:r>
                       <a:endParaRPr lang="en-US" sz="800" dirty="0"/>
@@ -15745,7 +16390,7 @@
                       <a:r>
                         <a:rPr lang="en-US" sz="800" b="1" dirty="0">
                           <a:solidFill>
-                            <a:srgbClr val="000000"/>
+                            <a:srgbClr val="8B5CF6"/>
                           </a:solidFill>
                         </a:rPr>
                         <a:t>16,671</a:t>
@@ -15801,14 +16446,14 @@
                         <a:buNone/>
                       </a:pPr>
                       <a:r>
-                        <a:rPr lang="en-US" sz="800" dirty="0">
+                        <a:rPr lang="en-US" sz="850" b="1" dirty="0">
                           <a:solidFill>
                             <a:srgbClr val="DC3545"/>
                           </a:solidFill>
                         </a:rPr>
-                        <a:t>-6,112</a:t>
-                      </a:r>
-                      <a:endParaRPr lang="en-US" sz="800" dirty="0"/>
+                        <a:t>-26.8%</a:t>
+                      </a:r>
+                      <a:endParaRPr lang="en-US" sz="850" dirty="0"/>
                     </a:p>
                   </a:txBody>
                   <a:tcPr marL="91440" marR="91440" marT="45720" marB="45720" anchor="ctr">
@@ -15861,10 +16506,10 @@
                       <a:r>
                         <a:rPr lang="en-US" sz="850" b="1" dirty="0">
                           <a:solidFill>
-                            <a:srgbClr val="DC3545"/>
-                          </a:solidFill>
-                        </a:rPr>
-                        <a:t>-26.8%</a:t>
+                            <a:srgbClr val="1B365D"/>
+                          </a:solidFill>
+                        </a:rPr>
+                        <a:t>+17.2%</a:t>
                       </a:r>
                       <a:endParaRPr lang="en-US" sz="850" dirty="0"/>
                     </a:p>
@@ -15979,8 +16624,8 @@
         </p:nvSpPr>
         <p:spPr>
           <a:xfrm>
-            <a:off x="7315200" y="2103120"/>
-            <a:ext cx="4389120" cy="1024128"/>
+            <a:off x="7406640" y="2103120"/>
+            <a:ext cx="4297680" cy="1024128"/>
           </a:xfrm>
           <a:prstGeom prst="roundRect">
             <a:avLst/>
@@ -16004,8 +16649,8 @@
         </p:nvSpPr>
         <p:spPr>
           <a:xfrm>
-            <a:off x="7452360" y="2176272"/>
-            <a:ext cx="4114800" cy="228600"/>
+            <a:off x="7543800" y="2176272"/>
+            <a:ext cx="4023360" cy="228600"/>
           </a:xfrm>
           <a:prstGeom prst="rect">
             <a:avLst/>
@@ -16040,8 +16685,8 @@
         </p:nvSpPr>
         <p:spPr>
           <a:xfrm>
-            <a:off x="7452360" y="2423160"/>
-            <a:ext cx="4114800" cy="640080"/>
+            <a:off x="7543800" y="2423160"/>
+            <a:ext cx="4023360" cy="640080"/>
           </a:xfrm>
           <a:prstGeom prst="rect">
             <a:avLst/>
@@ -16062,7 +16707,7 @@
                   <a:srgbClr val="155724"/>
                 </a:solidFill>
               </a:rPr>
-              <a:t>• Cairo (Noher Adel): 8,758 → 13,898 (+58.7%) | Pediamil AC (+225%)</a:t>
+              <a:t>• Cairo (Noher Adel): 7.2k ('25) → 8.8k (H1) → 13.9k/mo (Q3) (+58.7% vs H1 | +94.3% vs '25!)</a:t>
             </a:r>
             <a:endParaRPr lang="en-US" sz="800" dirty="0"/>
           </a:p>
@@ -16076,7 +16721,7 @@
                   <a:srgbClr val="155724"/>
                 </a:solidFill>
               </a:rPr>
-              <a:t>• KFR EL.SHK (Karim Shehab): 10,461 → 15,472 (+47.9%)</a:t>
+              <a:t>• KFR EL.SHK (Karim Shehab): 9.3k → 10.5k → 15.5k/mo (+47.9% vs H1 | +65.7% vs '25)</a:t>
             </a:r>
             <a:endParaRPr lang="en-US" sz="800" dirty="0"/>
           </a:p>
@@ -16090,7 +16735,7 @@
                   <a:srgbClr val="155724"/>
                 </a:solidFill>
               </a:rPr>
-              <a:t>• Upper Egypt I (UE North): 16,459 → 23,564 (+43.2%)</a:t>
+              <a:t>• Upper Egypt I (UE North): 12.9k → 16.5k → 23.6k/mo (+43.2% vs H1 | +83.0% vs '25)</a:t>
             </a:r>
             <a:endParaRPr lang="en-US" sz="800" dirty="0"/>
           </a:p>
@@ -16104,7 +16749,7 @@
                   <a:srgbClr val="155724"/>
                 </a:solidFill>
               </a:rPr>
-              <a:t>Strategic Action: Capitalize on doctor adoption; expand clinic quotas.</a:t>
+              <a:t>Strategic Action: Capitalize on breakout doctor adoption; expand NICU &amp; clinic quotas.</a:t>
             </a:r>
             <a:endParaRPr lang="en-US" sz="800" dirty="0"/>
           </a:p>
@@ -16118,8 +16763,8 @@
         </p:nvSpPr>
         <p:spPr>
           <a:xfrm>
-            <a:off x="7315200" y="3200400"/>
-            <a:ext cx="4389120" cy="1024128"/>
+            <a:off x="7406640" y="3200400"/>
+            <a:ext cx="4297680" cy="1024128"/>
           </a:xfrm>
           <a:prstGeom prst="roundRect">
             <a:avLst/>
@@ -16143,8 +16788,8 @@
         </p:nvSpPr>
         <p:spPr>
           <a:xfrm>
-            <a:off x="7452360" y="3273552"/>
-            <a:ext cx="4114800" cy="228600"/>
+            <a:off x="7543800" y="3273552"/>
+            <a:ext cx="4023360" cy="228600"/>
           </a:xfrm>
           <a:prstGeom prst="rect">
             <a:avLst/>
@@ -16179,8 +16824,8 @@
         </p:nvSpPr>
         <p:spPr>
           <a:xfrm>
-            <a:off x="7452360" y="3520440"/>
-            <a:ext cx="4114800" cy="640080"/>
+            <a:off x="7543800" y="3520440"/>
+            <a:ext cx="4023360" cy="640080"/>
           </a:xfrm>
           <a:prstGeom prst="rect">
             <a:avLst/>
@@ -16201,7 +16846,7 @@
                   <a:srgbClr val="0C5460"/>
                 </a:solidFill>
               </a:rPr>
-              <a:t>• Behera &amp; Dakahlia (Ahmed Sakr): 14,302 → 18,041 (+26.1%)</a:t>
+              <a:t>• Upper Egypt II (Beshoy Youhanna): 14.9k → 22.3k → 25.7k/mo (+15.2% vs H1 | +72.9% vs '25!)</a:t>
             </a:r>
             <a:endParaRPr lang="en-US" sz="800" dirty="0"/>
           </a:p>
@@ -16215,7 +16860,7 @@
                   <a:srgbClr val="0C5460"/>
                 </a:solidFill>
               </a:rPr>
-              <a:t>• Upper Egypt II (Beshoy Youhanna): 22,305 → 25,694 (+15.2%)</a:t>
+              <a:t>• Behera &amp; Dakahlia (Ahmed Sakr): 12.4k → 14.3k → 18.0k/mo (+26.1% vs H1 | +45.0% vs '25)</a:t>
             </a:r>
             <a:endParaRPr lang="en-US" sz="800" dirty="0"/>
           </a:p>
@@ -16229,7 +16874,7 @@
                   <a:srgbClr val="0C5460"/>
                 </a:solidFill>
               </a:rPr>
-              <a:t>Strategic Action: Maintain mega-volume leadership, defend hospital listings.</a:t>
+              <a:t>Strategic Action: Maintain national volume engine, defend hospital contracts.</a:t>
             </a:r>
             <a:endParaRPr lang="en-US" sz="800" dirty="0"/>
           </a:p>
@@ -16243,8 +16888,8 @@
         </p:nvSpPr>
         <p:spPr>
           <a:xfrm>
-            <a:off x="7315200" y="4297680"/>
-            <a:ext cx="4389120" cy="1024128"/>
+            <a:off x="7406640" y="4297680"/>
+            <a:ext cx="4297680" cy="1024128"/>
           </a:xfrm>
           <a:prstGeom prst="roundRect">
             <a:avLst/>
@@ -16268,8 +16913,8 @@
         </p:nvSpPr>
         <p:spPr>
           <a:xfrm>
-            <a:off x="7452360" y="4370832"/>
-            <a:ext cx="4114800" cy="228600"/>
+            <a:off x="7543800" y="4370832"/>
+            <a:ext cx="4023360" cy="228600"/>
           </a:xfrm>
           <a:prstGeom prst="rect">
             <a:avLst/>
@@ -16304,8 +16949,8 @@
         </p:nvSpPr>
         <p:spPr>
           <a:xfrm>
-            <a:off x="7452360" y="4617720"/>
-            <a:ext cx="4114800" cy="640080"/>
+            <a:off x="7543800" y="4617720"/>
+            <a:ext cx="4023360" cy="640080"/>
           </a:xfrm>
           <a:prstGeom prst="rect">
             <a:avLst/>
@@ -16326,7 +16971,7 @@
                   <a:srgbClr val="856404"/>
                 </a:solidFill>
               </a:rPr>
-              <a:t>• Guiza (Youstina Farag): 12,895 → 13,858 (+7.5%)</a:t>
+              <a:t>• Guiza (Youstina Farag): 10.0k → 12.9k → 13.9k/mo (+7.5% vs H1 | +39.3% vs '25)</a:t>
             </a:r>
             <a:endParaRPr lang="en-US" sz="800" dirty="0"/>
           </a:p>
@@ -16340,7 +16985,7 @@
                   <a:srgbClr val="856404"/>
                 </a:solidFill>
               </a:rPr>
-              <a:t>• Alexandria (Ahmed Hassan): 10,206 → 10,314 (+1.1%)</a:t>
+              <a:t>• Alexandria (Ahmed Hassan): 7.3k → 10.2k → 10.3k/mo (+1.1% vs H1 | +41.1% vs '25)</a:t>
             </a:r>
             <a:endParaRPr lang="en-US" sz="800" dirty="0"/>
           </a:p>
@@ -16368,8 +17013,8 @@
         </p:nvSpPr>
         <p:spPr>
           <a:xfrm>
-            <a:off x="7315200" y="5394960"/>
-            <a:ext cx="4389120" cy="1024128"/>
+            <a:off x="7406640" y="5394960"/>
+            <a:ext cx="4297680" cy="1024128"/>
           </a:xfrm>
           <a:prstGeom prst="roundRect">
             <a:avLst/>
@@ -16393,8 +17038,8 @@
         </p:nvSpPr>
         <p:spPr>
           <a:xfrm>
-            <a:off x="7452360" y="5468112"/>
-            <a:ext cx="4114800" cy="228600"/>
+            <a:off x="7543800" y="5468112"/>
+            <a:ext cx="4023360" cy="228600"/>
           </a:xfrm>
           <a:prstGeom prst="rect">
             <a:avLst/>
@@ -16429,8 +17074,8 @@
         </p:nvSpPr>
         <p:spPr>
           <a:xfrm>
-            <a:off x="7452360" y="5715000"/>
-            <a:ext cx="4114800" cy="640080"/>
+            <a:off x="7543800" y="5715000"/>
+            <a:ext cx="4023360" cy="640080"/>
           </a:xfrm>
           <a:prstGeom prst="rect">
             <a:avLst/>
@@ -16451,7 +17096,7 @@
                   <a:srgbClr val="721C24"/>
                 </a:solidFill>
               </a:rPr>
-              <a:t>• DELTA I (Shimaa Tarek): 20,146 → 18,614 (-7.6%)</a:t>
+              <a:t>• DELTA I (Shimaa Tarek): 15.2k → 20.1k → 18.6k/mo (-7.6% vs H1, but +22.2% vs '25)</a:t>
             </a:r>
             <a:endParaRPr lang="en-US" sz="800" dirty="0"/>
           </a:p>
@@ -16465,7 +17110,7 @@
                   <a:srgbClr val="721C24"/>
                 </a:solidFill>
               </a:rPr>
-              <a:t>• Delta II (Mohamed Yousef): 22,783 → 16,671 (-26.8%)</a:t>
+              <a:t>• Delta II (Mohamed Yousef): 14.2k → 22.8k → 16.7k/mo (-26.8% vs H1, but +17.2% vs '25)</a:t>
             </a:r>
             <a:endParaRPr lang="en-US" sz="800" dirty="0"/>
           </a:p>

</xml_diff>

<commit_message>
fix: resolve unclosed @media print CSS blocking passkey unlock and add quick-unlock support
</commit_message>
<xml_diff>
--- a/Egy_Nutri_Business_Review_Deck.pptx
+++ b/Egy_Nutri_Business_Review_Deck.pptx
@@ -1555,7 +1555,7 @@
             <c:size val="6"/>
             <c:spPr>
               <a:solidFill>
-                <a:srgbClr val="10B981"/>
+                <a:srgbClr val="F59E0B"/>
               </a:solidFill>
               <a:ln w="9525" cap="flat">
                 <a:solidFill>
@@ -1675,7 +1675,7 @@
             <c:size val="6"/>
             <c:spPr>
               <a:solidFill>
-                <a:srgbClr val="F59E0B"/>
+                <a:srgbClr val="10B981"/>
               </a:solidFill>
               <a:ln w="9525" cap="flat">
                 <a:solidFill>

</xml_diff>

<commit_message>
fix: resolve regex parse crash in verifyPassKey and remove all passkey disclosures from UI for strict confidentiality
</commit_message>
<xml_diff>
--- a/Egy_Nutri_Business_Review_Deck.pptx
+++ b/Egy_Nutri_Business_Review_Deck.pptx
@@ -1555,7 +1555,7 @@
             <c:size val="6"/>
             <c:spPr>
               <a:solidFill>
-                <a:srgbClr val="F59E0B"/>
+                <a:srgbClr val="10B981"/>
               </a:solidFill>
               <a:ln w="9525" cap="flat">
                 <a:solidFill>
@@ -1675,7 +1675,7 @@
             <c:size val="6"/>
             <c:spPr>
               <a:solidFill>
-                <a:srgbClr val="10B981"/>
+                <a:srgbClr val="F59E0B"/>
               </a:solidFill>
               <a:ln w="9525" cap="flat">
                 <a:solidFill>

</xml_diff>